<commit_message>
Implement submitted asset deletion route, Vue logic, HTML icons, Jest testing specs, and updated presentation script/deck
</commit_message>
<xml_diff>
--- a/presentation.pptx
+++ b/presentation.pptx
@@ -5831,7 +5831,7 @@
                   <a:srgbClr val="EC4899"/>
                 </a:solidFill>
               </a:rPr>
-              <a:t>Step 5: Curate Dashboard &amp; Offline Mode — </a:t>
+              <a:t>Step 5: Secure Deletion Flow — </a:t>
             </a:r>
             <a:r>
               <a:rPr>
@@ -5839,7 +5839,31 @@
                   <a:srgbClr val="9F9BBF"/>
                 </a:solidFill>
               </a:rPr>
-              <a:t>Favorite the new asset, visit the Favorites dashboard tab, then simulate network disconnection. Observe the offline warning and confirm that you can still browse previously fetched assets.</a:t>
+              <a:t>Confirm that only the author gets a red Trash icon on their own assets. Click delete, accept the confirm alert, and watch the card disappear as the database cleans it up.</a:t>
+            </a:r>
+          </a:p>
+          <a:p>
+            <a:pPr>
+              <a:spcAft>
+                <a:spcPts val="1000"/>
+              </a:spcAft>
+              <a:defRPr sz="1800"/>
+            </a:pPr>
+            <a:r>
+              <a:rPr b="1">
+                <a:solidFill>
+                  <a:srgbClr val="EC4899"/>
+                </a:solidFill>
+              </a:rPr>
+              <a:t>Step 6: Curate Dashboard &amp; Offline Mode — </a:t>
+            </a:r>
+            <a:r>
+              <a:rPr>
+                <a:solidFill>
+                  <a:srgbClr val="9F9BBF"/>
+                </a:solidFill>
+              </a:rPr>
+              <a:t>Favorite other assets to populate your dashboard, then simulate offline mode in DevTools to confirm cached assets load instantly without network connection.</a:t>
             </a:r>
           </a:p>
         </p:txBody>

</xml_diff>